<commit_message>
docs: real OpenAI change leads the video script, deck vocabulary, demo script
Co-Authored-By: Claude Sonnet 5.5 <noreply@anthropic.com>
</commit_message>
<xml_diff>
--- a/video-presentation/patchbay.pptx
+++ b/video-presentation/patchbay.pptx
@@ -505,7 +505,7 @@
           <a:p>
             <a:r>
               <a:rPr lang="en-US" dirty="0"/>
-              <a:t>Open on this slide while introducing the problem. 3 seconds.</a:t>
+              <a:t>Title. 3 seconds.</a:t>
             </a:r>
             <a:endParaRPr lang="en-US" dirty="0"/>
           </a:p>
@@ -593,7 +593,7 @@
           <a:p>
             <a:r>
               <a:rPr lang="en-US" dirty="0"/>
-              <a:t>Over 50 API vendors. Changelogs do not get read. 10 seconds.</a:t>
+              <a:t>At AWS, over 30% of downtime came from API changes nobody noticed. 10 seconds.</a:t>
             </a:r>
             <a:endParaRPr lang="en-US" dirty="0"/>
           </a:p>
@@ -681,7 +681,7 @@
           <a:p>
             <a:r>
               <a:rPr lang="en-US" dirty="0"/>
-              <a:t>Then run the live demo. About 10 seconds on this slide.</a:t>
+              <a:t>Optional. Real OpenAI change: model became required, user deprecated for safety_identifier.</a:t>
             </a:r>
             <a:endParaRPr lang="en-US" dirty="0"/>
           </a:p>
@@ -1144,7 +1144,7 @@
       </p:grpSpPr>
       <p:pic>
         <p:nvPicPr>
-          <p:cNvPr id="2" name="Logo" descr="/Users/tianzefang/Desktop/ClaudeCode/Projects/api-patchbay/slides/logo-amber.png">    </p:cNvPr>
+          <p:cNvPr id="2" name="Logo" descr="API Patchbay logo">    </p:cNvPr>
           <p:cNvPicPr>
             <a:picLocks noChangeAspect="1"/>
           </p:cNvPicPr>
@@ -1238,7 +1238,7 @@
                 <a:ea typeface="Calibri" pitchFamily="34" charset="-122"/>
                 <a:cs typeface="Calibri" pitchFamily="34" charset="-120"/>
               </a:rPr>
-              <a:t>When an API changes, every customer's code gets fixed.</a:t>
+              <a:t>When an API changes, every developer team gets a tested fix.</a:t>
             </a:r>
             <a:endParaRPr lang="en-US" sz="2200" dirty="0"/>
           </a:p>
@@ -1354,16 +1354,40 @@
           </a:p>
         </p:txBody>
       </p:sp>
-      <p:sp>
-        <p:nvSpPr>
-          <p:cNvPr id="3" name="Stat"/>
+      <p:pic>
+        <p:nvPicPr>
+          <p:cNvPr id="3" name="Downtime ring" descr="30% of AWS downtime came from external API and package changes">    </p:cNvPr>
+          <p:cNvPicPr>
+            <a:picLocks noChangeAspect="1"/>
+          </p:cNvPicPr>
+          <p:nvPr/>
+        </p:nvPicPr>
+        <p:blipFill>
+          <a:blip r:embed="rId1"/>
+          <a:stretch>
+            <a:fillRect/>
+          </a:stretch>
+        </p:blipFill>
+        <p:spPr>
+          <a:xfrm>
+            <a:off x="868680" y="1280160"/>
+            <a:ext cx="2926080" cy="2926080"/>
+          </a:xfrm>
+          <a:prstGeom prst="rect">
+            <a:avLst/>
+          </a:prstGeom>
+        </p:spPr>
+      </p:pic>
+      <p:sp>
+        <p:nvSpPr>
+          <p:cNvPr id="4" name="Doughnut center"/>
           <p:cNvSpPr txBox="1"/>
           <p:nvPr/>
         </p:nvSpPr>
         <p:spPr>
           <a:xfrm>
-            <a:off x="731520" y="1417320"/>
-            <a:ext cx="3291840" cy="1371600"/>
+            <a:off x="868680" y="1280160"/>
+            <a:ext cx="2926080" cy="2926080"/>
           </a:xfrm>
           <a:prstGeom prst="rect">
             <a:avLst/>
@@ -1375,11 +1399,11 @@
           <a:bodyPr wrap="square" lIns="0" tIns="0" rIns="0" bIns="0" rtlCol="0" anchor="ctr"/>
           <a:lstStyle/>
           <a:p>
-            <a:pPr indent="0" marL="0">
+            <a:pPr algn="ctr" indent="0" marL="0">
               <a:buNone/>
             </a:pPr>
             <a:r>
-              <a:rPr lang="en-US" sz="9600" b="1" dirty="0">
+              <a:rPr lang="en-US" sz="5400" b="1" dirty="0">
                 <a:solidFill>
                   <a:srgbClr val="F2A43A"/>
                 </a:solidFill>
@@ -1389,20 +1413,20 @@
               </a:rPr>
               <a:t>30%</a:t>
             </a:r>
-            <a:endParaRPr lang="en-US" sz="9600" dirty="0"/>
-          </a:p>
-        </p:txBody>
-      </p:sp>
-      <p:sp>
-        <p:nvSpPr>
-          <p:cNvPr id="4" name="Stat label"/>
+            <a:endParaRPr lang="en-US" sz="5400" dirty="0"/>
+          </a:p>
+        </p:txBody>
+      </p:sp>
+      <p:sp>
+        <p:nvSpPr>
+          <p:cNvPr id="5" name="Chart caption"/>
           <p:cNvSpPr txBox="1"/>
           <p:nvPr/>
         </p:nvSpPr>
         <p:spPr>
           <a:xfrm>
-            <a:off x="731520" y="2880360"/>
-            <a:ext cx="3291840" cy="1188720"/>
+            <a:off x="731520" y="4297680"/>
+            <a:ext cx="3200400" cy="457200"/>
           </a:xfrm>
           <a:prstGeom prst="rect">
             <a:avLst/>
@@ -1414,38 +1438,38 @@
           <a:bodyPr wrap="square" lIns="0" tIns="0" rIns="0" bIns="0" rtlCol="0" anchor="t"/>
           <a:lstStyle/>
           <a:p>
-            <a:pPr indent="0" marL="0">
+            <a:pPr algn="ctr" indent="0" marL="0">
               <a:buNone/>
             </a:pPr>
             <a:r>
-              <a:rPr lang="en-US" sz="1600" dirty="0">
+              <a:rPr lang="en-US" sz="1200" dirty="0">
                 <a:solidFill>
-                  <a:srgbClr val="F4F4F2"/>
+                  <a:srgbClr val="A3A7B0"/>
                 </a:solidFill>
                 <a:latin typeface="Calibri" pitchFamily="34" charset="0"/>
                 <a:ea typeface="Calibri" pitchFamily="34" charset="-122"/>
                 <a:cs typeface="Calibri" pitchFamily="34" charset="-120"/>
               </a:rPr>
-              <a:t>of service downtime at AWS came from external API and package changes nobody noticed (per the YC RFS author, ex-AWS).</a:t>
-            </a:r>
-            <a:endParaRPr lang="en-US" sz="1600" dirty="0"/>
-          </a:p>
-        </p:txBody>
-      </p:sp>
-      <p:sp>
-        <p:nvSpPr>
-          <p:cNvPr id="5" name="Card 1"/>
+              <a:t>of AWS downtime: API changes nobody noticed (RFS author, ex-AWS)</a:t>
+            </a:r>
+            <a:endParaRPr lang="en-US" sz="1200" dirty="0"/>
+          </a:p>
+        </p:txBody>
+      </p:sp>
+      <p:sp>
+        <p:nvSpPr>
+          <p:cNvPr id="6" name="Row card 1"/>
           <p:cNvSpPr/>
           <p:nvPr/>
         </p:nvSpPr>
         <p:spPr>
           <a:xfrm>
             <a:off x="4572000" y="1417320"/>
-            <a:ext cx="3840480" cy="868680"/>
+            <a:ext cx="3840480" cy="822960"/>
           </a:xfrm>
           <a:prstGeom prst="roundRect">
             <a:avLst>
-              <a:gd name="adj" fmla="val 8421"/>
+              <a:gd name="adj" fmla="val 8889"/>
             </a:avLst>
           </a:prstGeom>
           <a:solidFill>
@@ -1461,14 +1485,14 @@
       </p:sp>
       <p:sp>
         <p:nvSpPr>
-          <p:cNvPr id="6" name="Ring 1"/>
+          <p:cNvPr id="7" name="Row 1 ring"/>
           <p:cNvSpPr/>
           <p:nvPr/>
         </p:nvSpPr>
         <p:spPr>
           <a:xfrm>
-            <a:off x="4754880" y="1600200"/>
-            <a:ext cx="502920" cy="502920"/>
+            <a:off x="4754880" y="1554480"/>
+            <a:ext cx="548640" cy="548640"/>
           </a:xfrm>
           <a:prstGeom prst="ellipse">
             <a:avLst/>
@@ -1484,55 +1508,40 @@
           </a:ln>
         </p:spPr>
       </p:sp>
-      <p:sp>
-        <p:nvSpPr>
-          <p:cNvPr id="7" name="Ring 1 label"/>
+      <p:pic>
+        <p:nvPicPr>
+          <p:cNvPr id="8" name="Row 1 icon" descr="Row 1">    </p:cNvPr>
+          <p:cNvPicPr>
+            <a:picLocks noChangeAspect="1"/>
+          </p:cNvPicPr>
+          <p:nvPr/>
+        </p:nvPicPr>
+        <p:blipFill>
+          <a:blip r:embed="rId2"/>
+          <a:stretch>
+            <a:fillRect/>
+          </a:stretch>
+        </p:blipFill>
+        <p:spPr>
+          <a:xfrm>
+            <a:off x="4903013" y="1702613"/>
+            <a:ext cx="252374" cy="252374"/>
+          </a:xfrm>
+          <a:prstGeom prst="rect">
+            <a:avLst/>
+          </a:prstGeom>
+        </p:spPr>
+      </p:pic>
+      <p:sp>
+        <p:nvSpPr>
+          <p:cNvPr id="9" name="Row text 1"/>
           <p:cNvSpPr txBox="1"/>
           <p:nvPr/>
         </p:nvSpPr>
         <p:spPr>
           <a:xfrm>
-            <a:off x="4754880" y="1600200"/>
-            <a:ext cx="502920" cy="502920"/>
-          </a:xfrm>
-          <a:prstGeom prst="rect">
-            <a:avLst/>
-          </a:prstGeom>
-          <a:noFill/>
-          <a:ln/>
-        </p:spPr>
-        <p:txBody>
-          <a:bodyPr wrap="square" lIns="0" tIns="0" rIns="0" bIns="0" rtlCol="0" anchor="ctr"/>
-          <a:lstStyle/>
-          <a:p>
-            <a:pPr algn="ctr" indent="0" marL="0">
-              <a:buNone/>
-            </a:pPr>
-            <a:r>
-              <a:rPr lang="en-US" sz="1600" b="1" dirty="0">
-                <a:solidFill>
-                  <a:srgbClr val="F2A43A"/>
-                </a:solidFill>
-                <a:latin typeface="Calibri" pitchFamily="34" charset="0"/>
-                <a:ea typeface="Calibri" pitchFamily="34" charset="-122"/>
-                <a:cs typeface="Calibri" pitchFamily="34" charset="-120"/>
-              </a:rPr>
-              <a:t>1</a:t>
-            </a:r>
-            <a:endParaRPr lang="en-US" sz="1600" dirty="0"/>
-          </a:p>
-        </p:txBody>
-      </p:sp>
-      <p:sp>
-        <p:nvSpPr>
-          <p:cNvPr id="8" name="Card text 1"/>
-          <p:cNvSpPr txBox="1"/>
-          <p:nvPr/>
-        </p:nvSpPr>
-        <p:spPr>
-          <a:xfrm>
-            <a:off x="5440680" y="1417320"/>
-            <a:ext cx="2834640" cy="868680"/>
+            <a:off x="5486400" y="1417320"/>
+            <a:ext cx="2834640" cy="822960"/>
           </a:xfrm>
           <a:prstGeom prst="rect">
             <a:avLst/>
@@ -1556,43 +1565,26 @@
                 <a:ea typeface="Calibri" pitchFamily="34" charset="-122"/>
                 <a:cs typeface="Calibri" pitchFamily="34" charset="-120"/>
               </a:rPr>
-              <a:t>Breaking changes ship with little warning</a:t>
+              <a:t>Breaking changes, no warning</a:t>
             </a:r>
             <a:endParaRPr lang="en-US" sz="1600" dirty="0"/>
           </a:p>
-          <a:p>
-            <a:pPr indent="0" marL="0">
-              <a:buNone/>
-            </a:pPr>
-            <a:r>
-              <a:rPr lang="en-US" sz="1400" dirty="0">
-                <a:solidFill>
-                  <a:srgbClr val="A3A7B0"/>
-                </a:solidFill>
-                <a:latin typeface="Calibri" pitchFamily="34" charset="0"/>
-                <a:ea typeface="Calibri" pitchFamily="34" charset="-122"/>
-                <a:cs typeface="Calibri" pitchFamily="34" charset="-120"/>
-              </a:rPr>
-              <a:t>Integrations fail in production first.</a:t>
-            </a:r>
-            <a:endParaRPr lang="en-US" sz="1600" dirty="0"/>
-          </a:p>
-        </p:txBody>
-      </p:sp>
-      <p:sp>
-        <p:nvSpPr>
-          <p:cNvPr id="9" name="Card 2"/>
+        </p:txBody>
+      </p:sp>
+      <p:sp>
+        <p:nvSpPr>
+          <p:cNvPr id="10" name="Row card 2"/>
           <p:cNvSpPr/>
           <p:nvPr/>
         </p:nvSpPr>
         <p:spPr>
           <a:xfrm>
             <a:off x="4572000" y="2423160"/>
-            <a:ext cx="3840480" cy="868680"/>
+            <a:ext cx="3840480" cy="822960"/>
           </a:xfrm>
           <a:prstGeom prst="roundRect">
             <a:avLst>
-              <a:gd name="adj" fmla="val 8421"/>
+              <a:gd name="adj" fmla="val 8889"/>
             </a:avLst>
           </a:prstGeom>
           <a:solidFill>
@@ -1608,14 +1600,14 @@
       </p:sp>
       <p:sp>
         <p:nvSpPr>
-          <p:cNvPr id="10" name="Ring 2"/>
+          <p:cNvPr id="11" name="Row 2 ring"/>
           <p:cNvSpPr/>
           <p:nvPr/>
         </p:nvSpPr>
         <p:spPr>
           <a:xfrm>
-            <a:off x="4754880" y="2606040"/>
-            <a:ext cx="502920" cy="502920"/>
+            <a:off x="4754880" y="2560320"/>
+            <a:ext cx="548640" cy="548640"/>
           </a:xfrm>
           <a:prstGeom prst="ellipse">
             <a:avLst/>
@@ -1631,55 +1623,40 @@
           </a:ln>
         </p:spPr>
       </p:sp>
-      <p:sp>
-        <p:nvSpPr>
-          <p:cNvPr id="11" name="Ring 2 label"/>
+      <p:pic>
+        <p:nvPicPr>
+          <p:cNvPr id="12" name="Row 2 icon" descr="Row 2">    </p:cNvPr>
+          <p:cNvPicPr>
+            <a:picLocks noChangeAspect="1"/>
+          </p:cNvPicPr>
+          <p:nvPr/>
+        </p:nvPicPr>
+        <p:blipFill>
+          <a:blip r:embed="rId3"/>
+          <a:stretch>
+            <a:fillRect/>
+          </a:stretch>
+        </p:blipFill>
+        <p:spPr>
+          <a:xfrm>
+            <a:off x="4903013" y="2708453"/>
+            <a:ext cx="252374" cy="252374"/>
+          </a:xfrm>
+          <a:prstGeom prst="rect">
+            <a:avLst/>
+          </a:prstGeom>
+        </p:spPr>
+      </p:pic>
+      <p:sp>
+        <p:nvSpPr>
+          <p:cNvPr id="13" name="Row text 2"/>
           <p:cNvSpPr txBox="1"/>
           <p:nvPr/>
         </p:nvSpPr>
         <p:spPr>
           <a:xfrm>
-            <a:off x="4754880" y="2606040"/>
-            <a:ext cx="502920" cy="502920"/>
-          </a:xfrm>
-          <a:prstGeom prst="rect">
-            <a:avLst/>
-          </a:prstGeom>
-          <a:noFill/>
-          <a:ln/>
-        </p:spPr>
-        <p:txBody>
-          <a:bodyPr wrap="square" lIns="0" tIns="0" rIns="0" bIns="0" rtlCol="0" anchor="ctr"/>
-          <a:lstStyle/>
-          <a:p>
-            <a:pPr algn="ctr" indent="0" marL="0">
-              <a:buNone/>
-            </a:pPr>
-            <a:r>
-              <a:rPr lang="en-US" sz="1600" b="1" dirty="0">
-                <a:solidFill>
-                  <a:srgbClr val="F2A43A"/>
-                </a:solidFill>
-                <a:latin typeface="Calibri" pitchFamily="34" charset="0"/>
-                <a:ea typeface="Calibri" pitchFamily="34" charset="-122"/>
-                <a:cs typeface="Calibri" pitchFamily="34" charset="-120"/>
-              </a:rPr>
-              <a:t>2</a:t>
-            </a:r>
-            <a:endParaRPr lang="en-US" sz="1600" dirty="0"/>
-          </a:p>
-        </p:txBody>
-      </p:sp>
-      <p:sp>
-        <p:nvSpPr>
-          <p:cNvPr id="12" name="Card text 2"/>
-          <p:cNvSpPr txBox="1"/>
-          <p:nvPr/>
-        </p:nvSpPr>
-        <p:spPr>
-          <a:xfrm>
-            <a:off x="5440680" y="2423160"/>
-            <a:ext cx="2834640" cy="868680"/>
+            <a:off x="5486400" y="2423160"/>
+            <a:ext cx="2834640" cy="822960"/>
           </a:xfrm>
           <a:prstGeom prst="rect">
             <a:avLst/>
@@ -1703,43 +1680,26 @@
                 <a:ea typeface="Calibri" pitchFamily="34" charset="-122"/>
                 <a:cs typeface="Calibri" pitchFamily="34" charset="-120"/>
               </a:rPr>
-              <a:t>Useful features launch unnoticed</a:t>
+              <a:t>Useful features go unseen</a:t>
             </a:r>
             <a:endParaRPr lang="en-US" sz="1600" dirty="0"/>
           </a:p>
-          <a:p>
-            <a:pPr indent="0" marL="0">
-              <a:buNone/>
-            </a:pPr>
-            <a:r>
-              <a:rPr lang="en-US" sz="1400" dirty="0">
-                <a:solidFill>
-                  <a:srgbClr val="A3A7B0"/>
-                </a:solidFill>
-                <a:latin typeface="Calibri" pitchFamily="34" charset="0"/>
-                <a:ea typeface="Calibri" pitchFamily="34" charset="-122"/>
-                <a:cs typeface="Calibri" pitchFamily="34" charset="-120"/>
-              </a:rPr>
-              <a:t>Customers never adopt them.</a:t>
-            </a:r>
-            <a:endParaRPr lang="en-US" sz="1600" dirty="0"/>
-          </a:p>
-        </p:txBody>
-      </p:sp>
-      <p:sp>
-        <p:nvSpPr>
-          <p:cNvPr id="13" name="Card 3"/>
+        </p:txBody>
+      </p:sp>
+      <p:sp>
+        <p:nvSpPr>
+          <p:cNvPr id="14" name="Row card 3"/>
           <p:cNvSpPr/>
           <p:nvPr/>
         </p:nvSpPr>
         <p:spPr>
           <a:xfrm>
             <a:off x="4572000" y="3429000"/>
-            <a:ext cx="3840480" cy="868680"/>
+            <a:ext cx="3840480" cy="822960"/>
           </a:xfrm>
           <a:prstGeom prst="roundRect">
             <a:avLst>
-              <a:gd name="adj" fmla="val 8421"/>
+              <a:gd name="adj" fmla="val 8889"/>
             </a:avLst>
           </a:prstGeom>
           <a:solidFill>
@@ -1755,14 +1715,14 @@
       </p:sp>
       <p:sp>
         <p:nvSpPr>
-          <p:cNvPr id="14" name="Ring 3"/>
+          <p:cNvPr id="15" name="Row 3 ring"/>
           <p:cNvSpPr/>
           <p:nvPr/>
         </p:nvSpPr>
         <p:spPr>
           <a:xfrm>
-            <a:off x="4754880" y="3611880"/>
-            <a:ext cx="502920" cy="502920"/>
+            <a:off x="4754880" y="3566160"/>
+            <a:ext cx="548640" cy="548640"/>
           </a:xfrm>
           <a:prstGeom prst="ellipse">
             <a:avLst/>
@@ -1778,55 +1738,40 @@
           </a:ln>
         </p:spPr>
       </p:sp>
-      <p:sp>
-        <p:nvSpPr>
-          <p:cNvPr id="15" name="Ring 3 label"/>
+      <p:pic>
+        <p:nvPicPr>
+          <p:cNvPr id="16" name="Row 3 icon" descr="Row 3">    </p:cNvPr>
+          <p:cNvPicPr>
+            <a:picLocks noChangeAspect="1"/>
+          </p:cNvPicPr>
+          <p:nvPr/>
+        </p:nvPicPr>
+        <p:blipFill>
+          <a:blip r:embed="rId4"/>
+          <a:stretch>
+            <a:fillRect/>
+          </a:stretch>
+        </p:blipFill>
+        <p:spPr>
+          <a:xfrm>
+            <a:off x="4903013" y="3714293"/>
+            <a:ext cx="252374" cy="252374"/>
+          </a:xfrm>
+          <a:prstGeom prst="rect">
+            <a:avLst/>
+          </a:prstGeom>
+        </p:spPr>
+      </p:pic>
+      <p:sp>
+        <p:nvSpPr>
+          <p:cNvPr id="17" name="Row text 3"/>
           <p:cNvSpPr txBox="1"/>
           <p:nvPr/>
         </p:nvSpPr>
         <p:spPr>
           <a:xfrm>
-            <a:off x="4754880" y="3611880"/>
-            <a:ext cx="502920" cy="502920"/>
-          </a:xfrm>
-          <a:prstGeom prst="rect">
-            <a:avLst/>
-          </a:prstGeom>
-          <a:noFill/>
-          <a:ln/>
-        </p:spPr>
-        <p:txBody>
-          <a:bodyPr wrap="square" lIns="0" tIns="0" rIns="0" bIns="0" rtlCol="0" anchor="ctr"/>
-          <a:lstStyle/>
-          <a:p>
-            <a:pPr algn="ctr" indent="0" marL="0">
-              <a:buNone/>
-            </a:pPr>
-            <a:r>
-              <a:rPr lang="en-US" sz="1600" b="1" dirty="0">
-                <a:solidFill>
-                  <a:srgbClr val="F2A43A"/>
-                </a:solidFill>
-                <a:latin typeface="Calibri" pitchFamily="34" charset="0"/>
-                <a:ea typeface="Calibri" pitchFamily="34" charset="-122"/>
-                <a:cs typeface="Calibri" pitchFamily="34" charset="-120"/>
-              </a:rPr>
-              <a:t>3</a:t>
-            </a:r>
-            <a:endParaRPr lang="en-US" sz="1600" dirty="0"/>
-          </a:p>
-        </p:txBody>
-      </p:sp>
-      <p:sp>
-        <p:nvSpPr>
-          <p:cNvPr id="16" name="Card text 3"/>
-          <p:cNvSpPr txBox="1"/>
-          <p:nvPr/>
-        </p:nvSpPr>
-        <p:spPr>
-          <a:xfrm>
-            <a:off x="5440680" y="3429000"/>
-            <a:ext cx="2834640" cy="868680"/>
+            <a:off x="5486400" y="3429000"/>
+            <a:ext cx="2834640" cy="822960"/>
           </a:xfrm>
           <a:prstGeom prst="rect">
             <a:avLst/>
@@ -1850,24 +1795,7 @@
                 <a:ea typeface="Calibri" pitchFamily="34" charset="-122"/>
                 <a:cs typeface="Calibri" pitchFamily="34" charset="-120"/>
               </a:rPr>
-              <a:t>Fixing it meant editing every customer repo</a:t>
-            </a:r>
-            <a:endParaRPr lang="en-US" sz="1600" dirty="0"/>
-          </a:p>
-          <a:p>
-            <a:pPr indent="0" marL="0">
-              <a:buNone/>
-            </a:pPr>
-            <a:r>
-              <a:rPr lang="en-US" sz="1400" dirty="0">
-                <a:solidFill>
-                  <a:srgbClr val="A3A7B0"/>
-                </a:solidFill>
-                <a:latin typeface="Calibri" pitchFamily="34" charset="0"/>
-                <a:ea typeface="Calibri" pitchFamily="34" charset="-122"/>
-                <a:cs typeface="Calibri" pitchFamily="34" charset="-120"/>
-              </a:rPr>
-              <a:t>So providers announce and hope.</a:t>
+              <a:t>Changelogs go unread</a:t>
             </a:r>
             <a:endParaRPr lang="en-US" sz="1600" dirty="0"/>
           </a:p>
@@ -1946,41 +1874,14 @@
       </p:sp>
       <p:sp>
         <p:nvSpPr>
-          <p:cNvPr id="3" name="Step card 1"/>
+          <p:cNvPr id="3" name="Step 1 ring"/>
           <p:cNvSpPr/>
           <p:nvPr/>
         </p:nvSpPr>
         <p:spPr>
           <a:xfrm>
-            <a:off x="731520" y="1508760"/>
-            <a:ext cx="1645920" cy="2331720"/>
-          </a:xfrm>
-          <a:prstGeom prst="roundRect">
-            <a:avLst>
-              <a:gd name="adj" fmla="val 4444"/>
-            </a:avLst>
-          </a:prstGeom>
-          <a:solidFill>
-            <a:srgbClr val="1F222A"/>
-          </a:solidFill>
-          <a:ln w="9525">
-            <a:solidFill>
-              <a:srgbClr val="343843"/>
-            </a:solidFill>
-            <a:prstDash val="solid"/>
-          </a:ln>
-        </p:spPr>
-      </p:sp>
-      <p:sp>
-        <p:nvSpPr>
-          <p:cNvPr id="4" name="Step ring 1"/>
-          <p:cNvSpPr/>
-          <p:nvPr/>
-        </p:nvSpPr>
-        <p:spPr>
-          <a:xfrm>
-            <a:off x="868680" y="1691640"/>
-            <a:ext cx="457200" cy="457200"/>
+            <a:off x="1234440" y="1280160"/>
+            <a:ext cx="640080" cy="640080"/>
           </a:xfrm>
           <a:prstGeom prst="ellipse">
             <a:avLst/>
@@ -1996,16 +1897,40 @@
           </a:ln>
         </p:spPr>
       </p:sp>
-      <p:sp>
-        <p:nvSpPr>
-          <p:cNvPr id="5" name="Step ring 1 label"/>
+      <p:pic>
+        <p:nvPicPr>
+          <p:cNvPr id="4" name="Step 1 icon" descr="Step 1">    </p:cNvPr>
+          <p:cNvPicPr>
+            <a:picLocks noChangeAspect="1"/>
+          </p:cNvPicPr>
+          <p:nvPr/>
+        </p:nvPicPr>
+        <p:blipFill>
+          <a:blip r:embed="rId1"/>
+          <a:stretch>
+            <a:fillRect/>
+          </a:stretch>
+        </p:blipFill>
+        <p:spPr>
+          <a:xfrm>
+            <a:off x="1407262" y="1452982"/>
+            <a:ext cx="294437" cy="294437"/>
+          </a:xfrm>
+          <a:prstGeom prst="rect">
+            <a:avLst/>
+          </a:prstGeom>
+        </p:spPr>
+      </p:pic>
+      <p:sp>
+        <p:nvSpPr>
+          <p:cNvPr id="5" name="Step title 1"/>
           <p:cNvSpPr txBox="1"/>
           <p:nvPr/>
         </p:nvSpPr>
         <p:spPr>
           <a:xfrm>
-            <a:off x="868680" y="1691640"/>
-            <a:ext cx="457200" cy="457200"/>
+            <a:off x="731520" y="2011680"/>
+            <a:ext cx="1645920" cy="274320"/>
           </a:xfrm>
           <a:prstGeom prst="rect">
             <a:avLst/>
@@ -2014,7 +1939,7 @@
           <a:ln/>
         </p:spPr>
         <p:txBody>
-          <a:bodyPr wrap="square" lIns="0" tIns="0" rIns="0" bIns="0" rtlCol="0" anchor="ctr"/>
+          <a:bodyPr wrap="square" lIns="0" tIns="0" rIns="0" bIns="0" rtlCol="0" anchor="t"/>
           <a:lstStyle/>
           <a:p>
             <a:pPr algn="ctr" indent="0" marL="0">
@@ -2022,45 +1947,6 @@
             </a:pPr>
             <a:r>
               <a:rPr lang="en-US" sz="1600" b="1" dirty="0">
-                <a:solidFill>
-                  <a:srgbClr val="F2A43A"/>
-                </a:solidFill>
-                <a:latin typeface="Calibri" pitchFamily="34" charset="0"/>
-                <a:ea typeface="Calibri" pitchFamily="34" charset="-122"/>
-                <a:cs typeface="Calibri" pitchFamily="34" charset="-120"/>
-              </a:rPr>
-              <a:t>1</a:t>
-            </a:r>
-            <a:endParaRPr lang="en-US" sz="1600" dirty="0"/>
-          </a:p>
-        </p:txBody>
-      </p:sp>
-      <p:sp>
-        <p:nvSpPr>
-          <p:cNvPr id="6" name="Step title 1"/>
-          <p:cNvSpPr txBox="1"/>
-          <p:nvPr/>
-        </p:nvSpPr>
-        <p:spPr>
-          <a:xfrm>
-            <a:off x="868680" y="2286000"/>
-            <a:ext cx="1371600" cy="365760"/>
-          </a:xfrm>
-          <a:prstGeom prst="rect">
-            <a:avLst/>
-          </a:prstGeom>
-          <a:noFill/>
-          <a:ln/>
-        </p:spPr>
-        <p:txBody>
-          <a:bodyPr wrap="square" lIns="0" tIns="0" rIns="0" bIns="0" rtlCol="0" anchor="t"/>
-          <a:lstStyle/>
-          <a:p>
-            <a:pPr indent="0" marL="0">
-              <a:buNone/>
-            </a:pPr>
-            <a:r>
-              <a:rPr lang="en-US" sz="1800" b="1" dirty="0">
                 <a:solidFill>
                   <a:srgbClr val="F4F4F2"/>
                 </a:solidFill>
@@ -2070,20 +1956,20 @@
               </a:rPr>
               <a:t>Change feed</a:t>
             </a:r>
-            <a:endParaRPr lang="en-US" sz="1800" dirty="0"/>
-          </a:p>
-        </p:txBody>
-      </p:sp>
-      <p:sp>
-        <p:nvSpPr>
-          <p:cNvPr id="7" name="Step text 1"/>
+            <a:endParaRPr lang="en-US" sz="1600" dirty="0"/>
+          </a:p>
+        </p:txBody>
+      </p:sp>
+      <p:sp>
+        <p:nvSpPr>
+          <p:cNvPr id="6" name="Step text 1"/>
           <p:cNvSpPr txBox="1"/>
           <p:nvPr/>
         </p:nvSpPr>
         <p:spPr>
           <a:xfrm>
-            <a:off x="868680" y="2697480"/>
-            <a:ext cx="1371600" cy="1051560"/>
+            <a:off x="731520" y="2304288"/>
+            <a:ext cx="1645920" cy="457200"/>
           </a:xfrm>
           <a:prstGeom prst="rect">
             <a:avLst/>
@@ -2095,7 +1981,7 @@
           <a:bodyPr wrap="square" lIns="0" tIns="0" rIns="0" bIns="0" rtlCol="0" anchor="t"/>
           <a:lstStyle/>
           <a:p>
-            <a:pPr indent="0" marL="0">
+            <a:pPr algn="ctr" indent="0" marL="0">
               <a:buNone/>
             </a:pPr>
             <a:r>
@@ -2107,7 +1993,7 @@
                 <a:ea typeface="Calibri" pitchFamily="34" charset="-122"/>
                 <a:cs typeface="Calibri" pitchFamily="34" charset="-120"/>
               </a:rPr>
-              <a:t>Provider publishes changes.json from its OpenAPI spec.</a:t>
+              <a:t>Provider publishes</a:t>
             </a:r>
             <a:endParaRPr lang="en-US" sz="1400" dirty="0"/>
           </a:p>
@@ -2115,80 +2001,38 @@
       </p:sp>
       <p:sp>
         <p:nvSpPr>
-          <p:cNvPr id="8" name="Arrow 1"/>
-          <p:cNvSpPr txBox="1"/>
-          <p:nvPr/>
-        </p:nvSpPr>
-        <p:spPr>
-          <a:xfrm>
-            <a:off x="2377440" y="2468880"/>
-            <a:ext cx="365760" cy="365760"/>
-          </a:xfrm>
-          <a:prstGeom prst="rect">
+          <p:cNvPr id="7" name="Arrow 1"/>
+          <p:cNvSpPr/>
+          <p:nvPr/>
+        </p:nvSpPr>
+        <p:spPr>
+          <a:xfrm>
+            <a:off x="1965960" y="1600200"/>
+            <a:ext cx="777240" cy="0"/>
+          </a:xfrm>
+          <a:prstGeom prst="line">
             <a:avLst/>
           </a:prstGeom>
           <a:noFill/>
-          <a:ln/>
-        </p:spPr>
-        <p:txBody>
-          <a:bodyPr wrap="square" lIns="0" tIns="0" rIns="0" bIns="0" rtlCol="0" anchor="ctr"/>
-          <a:lstStyle/>
-          <a:p>
-            <a:pPr algn="ctr" indent="0" marL="0">
-              <a:buNone/>
-            </a:pPr>
-            <a:r>
-              <a:rPr lang="en-US" sz="2000" dirty="0">
-                <a:solidFill>
-                  <a:srgbClr val="F2A43A"/>
-                </a:solidFill>
-                <a:latin typeface="Calibri" pitchFamily="34" charset="0"/>
-                <a:ea typeface="Calibri" pitchFamily="34" charset="-122"/>
-                <a:cs typeface="Calibri" pitchFamily="34" charset="-120"/>
-              </a:rPr>
-              <a:t>→</a:t>
-            </a:r>
-            <a:endParaRPr lang="en-US" sz="2000" dirty="0"/>
-          </a:p>
-        </p:txBody>
-      </p:sp>
-      <p:sp>
-        <p:nvSpPr>
-          <p:cNvPr id="9" name="Step card 2"/>
-          <p:cNvSpPr/>
-          <p:nvPr/>
-        </p:nvSpPr>
-        <p:spPr>
-          <a:xfrm>
-            <a:off x="2743200" y="1508760"/>
-            <a:ext cx="1645920" cy="2331720"/>
-          </a:xfrm>
-          <a:prstGeom prst="roundRect">
-            <a:avLst>
-              <a:gd name="adj" fmla="val 4444"/>
-            </a:avLst>
-          </a:prstGeom>
-          <a:solidFill>
-            <a:srgbClr val="1F222A"/>
-          </a:solidFill>
-          <a:ln w="9525">
+          <a:ln w="19050">
             <a:solidFill>
-              <a:srgbClr val="343843"/>
+              <a:srgbClr val="F2A43A"/>
             </a:solidFill>
             <a:prstDash val="solid"/>
+            <a:tailEnd type="triangle"/>
           </a:ln>
         </p:spPr>
       </p:sp>
       <p:sp>
         <p:nvSpPr>
-          <p:cNvPr id="10" name="Step ring 2"/>
+          <p:cNvPr id="8" name="Step 2 ring"/>
           <p:cNvSpPr/>
           <p:nvPr/>
         </p:nvSpPr>
         <p:spPr>
           <a:xfrm>
-            <a:off x="2880360" y="1691640"/>
-            <a:ext cx="457200" cy="457200"/>
+            <a:off x="3246120" y="1280160"/>
+            <a:ext cx="640080" cy="640080"/>
           </a:xfrm>
           <a:prstGeom prst="ellipse">
             <a:avLst/>
@@ -2204,16 +2048,40 @@
           </a:ln>
         </p:spPr>
       </p:sp>
-      <p:sp>
-        <p:nvSpPr>
-          <p:cNvPr id="11" name="Step ring 2 label"/>
+      <p:pic>
+        <p:nvPicPr>
+          <p:cNvPr id="9" name="Step 2 icon" descr="Step 2">    </p:cNvPr>
+          <p:cNvPicPr>
+            <a:picLocks noChangeAspect="1"/>
+          </p:cNvPicPr>
+          <p:nvPr/>
+        </p:nvPicPr>
+        <p:blipFill>
+          <a:blip r:embed="rId2"/>
+          <a:stretch>
+            <a:fillRect/>
+          </a:stretch>
+        </p:blipFill>
+        <p:spPr>
+          <a:xfrm>
+            <a:off x="3418942" y="1452982"/>
+            <a:ext cx="294437" cy="294437"/>
+          </a:xfrm>
+          <a:prstGeom prst="rect">
+            <a:avLst/>
+          </a:prstGeom>
+        </p:spPr>
+      </p:pic>
+      <p:sp>
+        <p:nvSpPr>
+          <p:cNvPr id="10" name="Step title 2"/>
           <p:cNvSpPr txBox="1"/>
           <p:nvPr/>
         </p:nvSpPr>
         <p:spPr>
           <a:xfrm>
-            <a:off x="2880360" y="1691640"/>
-            <a:ext cx="457200" cy="457200"/>
+            <a:off x="2743200" y="2011680"/>
+            <a:ext cx="1645920" cy="274320"/>
           </a:xfrm>
           <a:prstGeom prst="rect">
             <a:avLst/>
@@ -2222,7 +2090,7 @@
           <a:ln/>
         </p:spPr>
         <p:txBody>
-          <a:bodyPr wrap="square" lIns="0" tIns="0" rIns="0" bIns="0" rtlCol="0" anchor="ctr"/>
+          <a:bodyPr wrap="square" lIns="0" tIns="0" rIns="0" bIns="0" rtlCol="0" anchor="t"/>
           <a:lstStyle/>
           <a:p>
             <a:pPr algn="ctr" indent="0" marL="0">
@@ -2230,45 +2098,6 @@
             </a:pPr>
             <a:r>
               <a:rPr lang="en-US" sz="1600" b="1" dirty="0">
-                <a:solidFill>
-                  <a:srgbClr val="F2A43A"/>
-                </a:solidFill>
-                <a:latin typeface="Calibri" pitchFamily="34" charset="0"/>
-                <a:ea typeface="Calibri" pitchFamily="34" charset="-122"/>
-                <a:cs typeface="Calibri" pitchFamily="34" charset="-120"/>
-              </a:rPr>
-              <a:t>2</a:t>
-            </a:r>
-            <a:endParaRPr lang="en-US" sz="1600" dirty="0"/>
-          </a:p>
-        </p:txBody>
-      </p:sp>
-      <p:sp>
-        <p:nvSpPr>
-          <p:cNvPr id="12" name="Step title 2"/>
-          <p:cNvSpPr txBox="1"/>
-          <p:nvPr/>
-        </p:nvSpPr>
-        <p:spPr>
-          <a:xfrm>
-            <a:off x="2880360" y="2286000"/>
-            <a:ext cx="1371600" cy="365760"/>
-          </a:xfrm>
-          <a:prstGeom prst="rect">
-            <a:avLst/>
-          </a:prstGeom>
-          <a:noFill/>
-          <a:ln/>
-        </p:spPr>
-        <p:txBody>
-          <a:bodyPr wrap="square" lIns="0" tIns="0" rIns="0" bIns="0" rtlCol="0" anchor="t"/>
-          <a:lstStyle/>
-          <a:p>
-            <a:pPr indent="0" marL="0">
-              <a:buNone/>
-            </a:pPr>
-            <a:r>
-              <a:rPr lang="en-US" sz="1800" b="1" dirty="0">
                 <a:solidFill>
                   <a:srgbClr val="F4F4F2"/>
                 </a:solidFill>
@@ -2278,20 +2107,20 @@
               </a:rPr>
               <a:t>Update agent</a:t>
             </a:r>
-            <a:endParaRPr lang="en-US" sz="1800" dirty="0"/>
-          </a:p>
-        </p:txBody>
-      </p:sp>
-      <p:sp>
-        <p:nvSpPr>
-          <p:cNvPr id="13" name="Step text 2"/>
+            <a:endParaRPr lang="en-US" sz="1600" dirty="0"/>
+          </a:p>
+        </p:txBody>
+      </p:sp>
+      <p:sp>
+        <p:nvSpPr>
+          <p:cNvPr id="11" name="Step text 2"/>
           <p:cNvSpPr txBox="1"/>
           <p:nvPr/>
         </p:nvSpPr>
         <p:spPr>
           <a:xfrm>
-            <a:off x="2880360" y="2697480"/>
-            <a:ext cx="1371600" cy="1051560"/>
+            <a:off x="2743200" y="2304288"/>
+            <a:ext cx="1645920" cy="457200"/>
           </a:xfrm>
           <a:prstGeom prst="rect">
             <a:avLst/>
@@ -2303,7 +2132,7 @@
           <a:bodyPr wrap="square" lIns="0" tIns="0" rIns="0" bIns="0" rtlCol="0" anchor="t"/>
           <a:lstStyle/>
           <a:p>
-            <a:pPr indent="0" marL="0">
+            <a:pPr algn="ctr" indent="0" marL="0">
               <a:buNone/>
             </a:pPr>
             <a:r>
@@ -2315,7 +2144,7 @@
                 <a:ea typeface="Calibri" pitchFamily="34" charset="-122"/>
                 <a:cs typeface="Calibri" pitchFamily="34" charset="-120"/>
               </a:rPr>
-              <a:t>Finds affected calls and writes a patch.</a:t>
+              <a:t>Patches the code</a:t>
             </a:r>
             <a:endParaRPr lang="en-US" sz="1400" dirty="0"/>
           </a:p>
@@ -2323,80 +2152,38 @@
       </p:sp>
       <p:sp>
         <p:nvSpPr>
-          <p:cNvPr id="14" name="Arrow 2"/>
-          <p:cNvSpPr txBox="1"/>
-          <p:nvPr/>
-        </p:nvSpPr>
-        <p:spPr>
-          <a:xfrm>
-            <a:off x="4389120" y="2468880"/>
-            <a:ext cx="365760" cy="365760"/>
-          </a:xfrm>
-          <a:prstGeom prst="rect">
+          <p:cNvPr id="12" name="Arrow 2"/>
+          <p:cNvSpPr/>
+          <p:nvPr/>
+        </p:nvSpPr>
+        <p:spPr>
+          <a:xfrm>
+            <a:off x="3977640" y="1600200"/>
+            <a:ext cx="777240" cy="0"/>
+          </a:xfrm>
+          <a:prstGeom prst="line">
             <a:avLst/>
           </a:prstGeom>
           <a:noFill/>
-          <a:ln/>
-        </p:spPr>
-        <p:txBody>
-          <a:bodyPr wrap="square" lIns="0" tIns="0" rIns="0" bIns="0" rtlCol="0" anchor="ctr"/>
-          <a:lstStyle/>
-          <a:p>
-            <a:pPr algn="ctr" indent="0" marL="0">
-              <a:buNone/>
-            </a:pPr>
-            <a:r>
-              <a:rPr lang="en-US" sz="2000" dirty="0">
-                <a:solidFill>
-                  <a:srgbClr val="F2A43A"/>
-                </a:solidFill>
-                <a:latin typeface="Calibri" pitchFamily="34" charset="0"/>
-                <a:ea typeface="Calibri" pitchFamily="34" charset="-122"/>
-                <a:cs typeface="Calibri" pitchFamily="34" charset="-120"/>
-              </a:rPr>
-              <a:t>→</a:t>
-            </a:r>
-            <a:endParaRPr lang="en-US" sz="2000" dirty="0"/>
-          </a:p>
-        </p:txBody>
-      </p:sp>
-      <p:sp>
-        <p:nvSpPr>
-          <p:cNvPr id="15" name="Step card 3"/>
-          <p:cNvSpPr/>
-          <p:nvPr/>
-        </p:nvSpPr>
-        <p:spPr>
-          <a:xfrm>
-            <a:off x="4754880" y="1508760"/>
-            <a:ext cx="1645920" cy="2331720"/>
-          </a:xfrm>
-          <a:prstGeom prst="roundRect">
-            <a:avLst>
-              <a:gd name="adj" fmla="val 4444"/>
-            </a:avLst>
-          </a:prstGeom>
-          <a:solidFill>
-            <a:srgbClr val="1F222A"/>
-          </a:solidFill>
-          <a:ln w="9525">
+          <a:ln w="19050">
             <a:solidFill>
-              <a:srgbClr val="343843"/>
+              <a:srgbClr val="F2A43A"/>
             </a:solidFill>
             <a:prstDash val="solid"/>
+            <a:tailEnd type="triangle"/>
           </a:ln>
         </p:spPr>
       </p:sp>
       <p:sp>
         <p:nvSpPr>
-          <p:cNvPr id="16" name="Step ring 3"/>
+          <p:cNvPr id="13" name="Step 3 ring"/>
           <p:cNvSpPr/>
           <p:nvPr/>
         </p:nvSpPr>
         <p:spPr>
           <a:xfrm>
-            <a:off x="4892040" y="1691640"/>
-            <a:ext cx="457200" cy="457200"/>
+            <a:off x="5257800" y="1280160"/>
+            <a:ext cx="640080" cy="640080"/>
           </a:xfrm>
           <a:prstGeom prst="ellipse">
             <a:avLst/>
@@ -2412,16 +2199,40 @@
           </a:ln>
         </p:spPr>
       </p:sp>
-      <p:sp>
-        <p:nvSpPr>
-          <p:cNvPr id="17" name="Step ring 3 label"/>
+      <p:pic>
+        <p:nvPicPr>
+          <p:cNvPr id="14" name="Step 3 icon" descr="Step 3">    </p:cNvPr>
+          <p:cNvPicPr>
+            <a:picLocks noChangeAspect="1"/>
+          </p:cNvPicPr>
+          <p:nvPr/>
+        </p:nvPicPr>
+        <p:blipFill>
+          <a:blip r:embed="rId3"/>
+          <a:stretch>
+            <a:fillRect/>
+          </a:stretch>
+        </p:blipFill>
+        <p:spPr>
+          <a:xfrm>
+            <a:off x="5430622" y="1452982"/>
+            <a:ext cx="294437" cy="294437"/>
+          </a:xfrm>
+          <a:prstGeom prst="rect">
+            <a:avLst/>
+          </a:prstGeom>
+        </p:spPr>
+      </p:pic>
+      <p:sp>
+        <p:nvSpPr>
+          <p:cNvPr id="15" name="Step title 3"/>
           <p:cNvSpPr txBox="1"/>
           <p:nvPr/>
         </p:nvSpPr>
         <p:spPr>
           <a:xfrm>
-            <a:off x="4892040" y="1691640"/>
-            <a:ext cx="457200" cy="457200"/>
+            <a:off x="4754880" y="2011680"/>
+            <a:ext cx="1645920" cy="274320"/>
           </a:xfrm>
           <a:prstGeom prst="rect">
             <a:avLst/>
@@ -2430,7 +2241,7 @@
           <a:ln/>
         </p:spPr>
         <p:txBody>
-          <a:bodyPr wrap="square" lIns="0" tIns="0" rIns="0" bIns="0" rtlCol="0" anchor="ctr"/>
+          <a:bodyPr wrap="square" lIns="0" tIns="0" rIns="0" bIns="0" rtlCol="0" anchor="t"/>
           <a:lstStyle/>
           <a:p>
             <a:pPr algn="ctr" indent="0" marL="0">
@@ -2438,45 +2249,6 @@
             </a:pPr>
             <a:r>
               <a:rPr lang="en-US" sz="1600" b="1" dirty="0">
-                <a:solidFill>
-                  <a:srgbClr val="F2A43A"/>
-                </a:solidFill>
-                <a:latin typeface="Calibri" pitchFamily="34" charset="0"/>
-                <a:ea typeface="Calibri" pitchFamily="34" charset="-122"/>
-                <a:cs typeface="Calibri" pitchFamily="34" charset="-120"/>
-              </a:rPr>
-              <a:t>3</a:t>
-            </a:r>
-            <a:endParaRPr lang="en-US" sz="1600" dirty="0"/>
-          </a:p>
-        </p:txBody>
-      </p:sp>
-      <p:sp>
-        <p:nvSpPr>
-          <p:cNvPr id="18" name="Step title 3"/>
-          <p:cNvSpPr txBox="1"/>
-          <p:nvPr/>
-        </p:nvSpPr>
-        <p:spPr>
-          <a:xfrm>
-            <a:off x="4892040" y="2286000"/>
-            <a:ext cx="1371600" cy="365760"/>
-          </a:xfrm>
-          <a:prstGeom prst="rect">
-            <a:avLst/>
-          </a:prstGeom>
-          <a:noFill/>
-          <a:ln/>
-        </p:spPr>
-        <p:txBody>
-          <a:bodyPr wrap="square" lIns="0" tIns="0" rIns="0" bIns="0" rtlCol="0" anchor="t"/>
-          <a:lstStyle/>
-          <a:p>
-            <a:pPr indent="0" marL="0">
-              <a:buNone/>
-            </a:pPr>
-            <a:r>
-              <a:rPr lang="en-US" sz="1800" b="1" dirty="0">
                 <a:solidFill>
                   <a:srgbClr val="F4F4F2"/>
                 </a:solidFill>
@@ -2486,20 +2258,20 @@
               </a:rPr>
               <a:t>Freestyle VM</a:t>
             </a:r>
-            <a:endParaRPr lang="en-US" sz="1800" dirty="0"/>
-          </a:p>
-        </p:txBody>
-      </p:sp>
-      <p:sp>
-        <p:nvSpPr>
-          <p:cNvPr id="19" name="Step text 3"/>
+            <a:endParaRPr lang="en-US" sz="1600" dirty="0"/>
+          </a:p>
+        </p:txBody>
+      </p:sp>
+      <p:sp>
+        <p:nvSpPr>
+          <p:cNvPr id="16" name="Step text 3"/>
           <p:cNvSpPr txBox="1"/>
           <p:nvPr/>
         </p:nvSpPr>
         <p:spPr>
           <a:xfrm>
-            <a:off x="4892040" y="2697480"/>
-            <a:ext cx="1371600" cy="1051560"/>
+            <a:off x="4754880" y="2304288"/>
+            <a:ext cx="1645920" cy="457200"/>
           </a:xfrm>
           <a:prstGeom prst="rect">
             <a:avLst/>
@@ -2511,7 +2283,7 @@
           <a:bodyPr wrap="square" lIns="0" tIns="0" rIns="0" bIns="0" rtlCol="0" anchor="t"/>
           <a:lstStyle/>
           <a:p>
-            <a:pPr indent="0" marL="0">
+            <a:pPr algn="ctr" indent="0" marL="0">
               <a:buNone/>
             </a:pPr>
             <a:r>
@@ -2523,7 +2295,7 @@
                 <a:ea typeface="Calibri" pitchFamily="34" charset="-122"/>
                 <a:cs typeface="Calibri" pitchFamily="34" charset="-120"/>
               </a:rPr>
-              <a:t>Tests the patch in a clean VM. Retries from a snapshot.</a:t>
+              <a:t>Tests in a clean VM</a:t>
             </a:r>
             <a:endParaRPr lang="en-US" sz="1400" dirty="0"/>
           </a:p>
@@ -2531,80 +2303,38 @@
       </p:sp>
       <p:sp>
         <p:nvSpPr>
-          <p:cNvPr id="20" name="Arrow 3"/>
-          <p:cNvSpPr txBox="1"/>
-          <p:nvPr/>
-        </p:nvSpPr>
-        <p:spPr>
-          <a:xfrm>
-            <a:off x="6400800" y="2468880"/>
-            <a:ext cx="365760" cy="365760"/>
-          </a:xfrm>
-          <a:prstGeom prst="rect">
+          <p:cNvPr id="17" name="Arrow 3"/>
+          <p:cNvSpPr/>
+          <p:nvPr/>
+        </p:nvSpPr>
+        <p:spPr>
+          <a:xfrm>
+            <a:off x="5989320" y="1600200"/>
+            <a:ext cx="777240" cy="0"/>
+          </a:xfrm>
+          <a:prstGeom prst="line">
             <a:avLst/>
           </a:prstGeom>
           <a:noFill/>
-          <a:ln/>
-        </p:spPr>
-        <p:txBody>
-          <a:bodyPr wrap="square" lIns="0" tIns="0" rIns="0" bIns="0" rtlCol="0" anchor="ctr"/>
-          <a:lstStyle/>
-          <a:p>
-            <a:pPr algn="ctr" indent="0" marL="0">
-              <a:buNone/>
-            </a:pPr>
-            <a:r>
-              <a:rPr lang="en-US" sz="2000" dirty="0">
-                <a:solidFill>
-                  <a:srgbClr val="F2A43A"/>
-                </a:solidFill>
-                <a:latin typeface="Calibri" pitchFamily="34" charset="0"/>
-                <a:ea typeface="Calibri" pitchFamily="34" charset="-122"/>
-                <a:cs typeface="Calibri" pitchFamily="34" charset="-120"/>
-              </a:rPr>
-              <a:t>→</a:t>
-            </a:r>
-            <a:endParaRPr lang="en-US" sz="2000" dirty="0"/>
-          </a:p>
-        </p:txBody>
-      </p:sp>
-      <p:sp>
-        <p:nvSpPr>
-          <p:cNvPr id="21" name="Step card 4"/>
-          <p:cNvSpPr/>
-          <p:nvPr/>
-        </p:nvSpPr>
-        <p:spPr>
-          <a:xfrm>
-            <a:off x="6766560" y="1508760"/>
-            <a:ext cx="1645920" cy="2331720"/>
-          </a:xfrm>
-          <a:prstGeom prst="roundRect">
-            <a:avLst>
-              <a:gd name="adj" fmla="val 4444"/>
-            </a:avLst>
-          </a:prstGeom>
-          <a:solidFill>
-            <a:srgbClr val="1F222A"/>
-          </a:solidFill>
-          <a:ln w="9525">
+          <a:ln w="19050">
             <a:solidFill>
-              <a:srgbClr val="343843"/>
+              <a:srgbClr val="F2A43A"/>
             </a:solidFill>
             <a:prstDash val="solid"/>
+            <a:tailEnd type="triangle"/>
           </a:ln>
         </p:spPr>
       </p:sp>
       <p:sp>
         <p:nvSpPr>
-          <p:cNvPr id="22" name="Step ring 4"/>
+          <p:cNvPr id="18" name="Step 4 ring"/>
           <p:cNvSpPr/>
           <p:nvPr/>
         </p:nvSpPr>
         <p:spPr>
           <a:xfrm>
-            <a:off x="6903720" y="1691640"/>
-            <a:ext cx="457200" cy="457200"/>
+            <a:off x="7269480" y="1280160"/>
+            <a:ext cx="640080" cy="640080"/>
           </a:xfrm>
           <a:prstGeom prst="ellipse">
             <a:avLst/>
@@ -2620,16 +2350,40 @@
           </a:ln>
         </p:spPr>
       </p:sp>
-      <p:sp>
-        <p:nvSpPr>
-          <p:cNvPr id="23" name="Step ring 4 label"/>
+      <p:pic>
+        <p:nvPicPr>
+          <p:cNvPr id="19" name="Step 4 icon" descr="Step 4">    </p:cNvPr>
+          <p:cNvPicPr>
+            <a:picLocks noChangeAspect="1"/>
+          </p:cNvPicPr>
+          <p:nvPr/>
+        </p:nvPicPr>
+        <p:blipFill>
+          <a:blip r:embed="rId4"/>
+          <a:stretch>
+            <a:fillRect/>
+          </a:stretch>
+        </p:blipFill>
+        <p:spPr>
+          <a:xfrm>
+            <a:off x="7442302" y="1452982"/>
+            <a:ext cx="294437" cy="294437"/>
+          </a:xfrm>
+          <a:prstGeom prst="rect">
+            <a:avLst/>
+          </a:prstGeom>
+        </p:spPr>
+      </p:pic>
+      <p:sp>
+        <p:nvSpPr>
+          <p:cNvPr id="20" name="Step title 4"/>
           <p:cNvSpPr txBox="1"/>
           <p:nvPr/>
         </p:nvSpPr>
         <p:spPr>
           <a:xfrm>
-            <a:off x="6903720" y="1691640"/>
-            <a:ext cx="457200" cy="457200"/>
+            <a:off x="6766560" y="2011680"/>
+            <a:ext cx="1645920" cy="274320"/>
           </a:xfrm>
           <a:prstGeom prst="rect">
             <a:avLst/>
@@ -2638,7 +2392,7 @@
           <a:ln/>
         </p:spPr>
         <p:txBody>
-          <a:bodyPr wrap="square" lIns="0" tIns="0" rIns="0" bIns="0" rtlCol="0" anchor="ctr"/>
+          <a:bodyPr wrap="square" lIns="0" tIns="0" rIns="0" bIns="0" rtlCol="0" anchor="t"/>
           <a:lstStyle/>
           <a:p>
             <a:pPr algn="ctr" indent="0" marL="0">
@@ -2646,45 +2400,6 @@
             </a:pPr>
             <a:r>
               <a:rPr lang="en-US" sz="1600" b="1" dirty="0">
-                <a:solidFill>
-                  <a:srgbClr val="F2A43A"/>
-                </a:solidFill>
-                <a:latin typeface="Calibri" pitchFamily="34" charset="0"/>
-                <a:ea typeface="Calibri" pitchFamily="34" charset="-122"/>
-                <a:cs typeface="Calibri" pitchFamily="34" charset="-120"/>
-              </a:rPr>
-              <a:t>4</a:t>
-            </a:r>
-            <a:endParaRPr lang="en-US" sz="1600" dirty="0"/>
-          </a:p>
-        </p:txBody>
-      </p:sp>
-      <p:sp>
-        <p:nvSpPr>
-          <p:cNvPr id="24" name="Step title 4"/>
-          <p:cNvSpPr txBox="1"/>
-          <p:nvPr/>
-        </p:nvSpPr>
-        <p:spPr>
-          <a:xfrm>
-            <a:off x="6903720" y="2286000"/>
-            <a:ext cx="1371600" cy="365760"/>
-          </a:xfrm>
-          <a:prstGeom prst="rect">
-            <a:avLst/>
-          </a:prstGeom>
-          <a:noFill/>
-          <a:ln/>
-        </p:spPr>
-        <p:txBody>
-          <a:bodyPr wrap="square" lIns="0" tIns="0" rIns="0" bIns="0" rtlCol="0" anchor="t"/>
-          <a:lstStyle/>
-          <a:p>
-            <a:pPr indent="0" marL="0">
-              <a:buNone/>
-            </a:pPr>
-            <a:r>
-              <a:rPr lang="en-US" sz="1800" b="1" dirty="0">
                 <a:solidFill>
                   <a:srgbClr val="F4F4F2"/>
                 </a:solidFill>
@@ -2694,20 +2409,20 @@
               </a:rPr>
               <a:t>Pull request</a:t>
             </a:r>
-            <a:endParaRPr lang="en-US" sz="1800" dirty="0"/>
-          </a:p>
-        </p:txBody>
-      </p:sp>
-      <p:sp>
-        <p:nvSpPr>
-          <p:cNvPr id="25" name="Step text 4"/>
+            <a:endParaRPr lang="en-US" sz="1600" dirty="0"/>
+          </a:p>
+        </p:txBody>
+      </p:sp>
+      <p:sp>
+        <p:nvSpPr>
+          <p:cNvPr id="21" name="Step text 4"/>
           <p:cNvSpPr txBox="1"/>
           <p:nvPr/>
         </p:nvSpPr>
         <p:spPr>
           <a:xfrm>
-            <a:off x="6903720" y="2697480"/>
-            <a:ext cx="1371600" cy="1051560"/>
+            <a:off x="6766560" y="2304288"/>
+            <a:ext cx="1645920" cy="457200"/>
           </a:xfrm>
           <a:prstGeom prst="rect">
             <a:avLst/>
@@ -2719,7 +2434,7 @@
           <a:bodyPr wrap="square" lIns="0" tIns="0" rIns="0" bIns="0" rtlCol="0" anchor="t"/>
           <a:lstStyle/>
           <a:p>
-            <a:pPr indent="0" marL="0">
+            <a:pPr algn="ctr" indent="0" marL="0">
               <a:buNone/>
             </a:pPr>
             <a:r>
@@ -2731,7 +2446,7 @@
                 <a:ea typeface="Calibri" pitchFamily="34" charset="-122"/>
                 <a:cs typeface="Calibri" pitchFamily="34" charset="-120"/>
               </a:rPr>
-              <a:t>Diff plus test result. A human merges.</a:t>
+              <a:t>Dev team merges</a:t>
             </a:r>
             <a:endParaRPr lang="en-US" sz="1400" dirty="0"/>
           </a:p>
@@ -2739,14 +2454,41 @@
       </p:sp>
       <p:sp>
         <p:nvSpPr>
-          <p:cNvPr id="26" name="Caption"/>
+          <p:cNvPr id="22" name="Diff card"/>
+          <p:cNvSpPr/>
+          <p:nvPr/>
+        </p:nvSpPr>
+        <p:spPr>
+          <a:xfrm>
+            <a:off x="731520" y="3017520"/>
+            <a:ext cx="7680960" cy="1600200"/>
+          </a:xfrm>
+          <a:prstGeom prst="roundRect">
+            <a:avLst>
+              <a:gd name="adj" fmla="val 4571"/>
+            </a:avLst>
+          </a:prstGeom>
+          <a:solidFill>
+            <a:srgbClr val="0F1115"/>
+          </a:solidFill>
+          <a:ln w="9525">
+            <a:solidFill>
+              <a:srgbClr val="343843"/>
+            </a:solidFill>
+            <a:prstDash val="solid"/>
+          </a:ln>
+        </p:spPr>
+      </p:sp>
+      <p:sp>
+        <p:nvSpPr>
+          <p:cNvPr id="23" name="Diff file"/>
           <p:cNvSpPr txBox="1"/>
           <p:nvPr/>
         </p:nvSpPr>
         <p:spPr>
           <a:xfrm>
-            <a:off x="731520" y="4160520"/>
-            <a:ext cx="7680960" cy="365760"/>
+            <a:off x="960120" y="3154680"/>
+            <a:ext cx="4114800" cy="274320"/>
           </a:xfrm>
           <a:prstGeom prst="rect">
             <a:avLst/>
@@ -2762,17 +2504,200 @@
               <a:buNone/>
             </a:pPr>
             <a:r>
-              <a:rPr lang="en-US" sz="1600" dirty="0">
+              <a:rPr lang="en-US" sz="1200" dirty="0">
                 <a:solidFill>
-                  <a:srgbClr val="F4F4F2"/>
+                  <a:srgbClr val="A3A7B0"/>
+                </a:solidFill>
+                <a:latin typeface="Courier New" pitchFamily="34" charset="0"/>
+                <a:ea typeface="Courier New" pitchFamily="34" charset="-122"/>
+                <a:cs typeface="Courier New" pitchFamily="34" charset="-120"/>
+              </a:rPr>
+              <a:t>company-repo / images.js</a:t>
+            </a:r>
+            <a:endParaRPr lang="en-US" sz="1200" dirty="0"/>
+          </a:p>
+        </p:txBody>
+      </p:sp>
+      <p:sp>
+        <p:nvSpPr>
+          <p:cNvPr id="24" name="Pass badge"/>
+          <p:cNvSpPr/>
+          <p:nvPr/>
+        </p:nvSpPr>
+        <p:spPr>
+          <a:xfrm>
+            <a:off x="6720840" y="3136392"/>
+            <a:ext cx="1508760" cy="292608"/>
+          </a:xfrm>
+          <a:prstGeom prst="roundRect">
+            <a:avLst>
+              <a:gd name="adj" fmla="val 50000"/>
+            </a:avLst>
+          </a:prstGeom>
+          <a:solidFill>
+            <a:srgbClr val="0F1115"/>
+          </a:solidFill>
+          <a:ln w="15875">
+            <a:solidFill>
+              <a:srgbClr val="4CC38A"/>
+            </a:solidFill>
+            <a:prstDash val="solid"/>
+          </a:ln>
+        </p:spPr>
+      </p:sp>
+      <p:sp>
+        <p:nvSpPr>
+          <p:cNvPr id="25" name="Pass badge text"/>
+          <p:cNvSpPr txBox="1"/>
+          <p:nvPr/>
+        </p:nvSpPr>
+        <p:spPr>
+          <a:xfrm>
+            <a:off x="6720840" y="3136392"/>
+            <a:ext cx="1508760" cy="292608"/>
+          </a:xfrm>
+          <a:prstGeom prst="rect">
+            <a:avLst/>
+          </a:prstGeom>
+          <a:noFill/>
+          <a:ln/>
+        </p:spPr>
+        <p:txBody>
+          <a:bodyPr wrap="square" lIns="0" tIns="0" rIns="0" bIns="0" rtlCol="0" anchor="ctr"/>
+          <a:lstStyle/>
+          <a:p>
+            <a:pPr algn="ctr" indent="0" marL="0">
+              <a:buNone/>
+            </a:pPr>
+            <a:r>
+              <a:rPr lang="en-US" sz="1200" b="1" dirty="0">
+                <a:solidFill>
+                  <a:srgbClr val="4CC38A"/>
                 </a:solidFill>
                 <a:latin typeface="Calibri" pitchFamily="34" charset="0"/>
                 <a:ea typeface="Calibri" pitchFamily="34" charset="-122"/>
                 <a:cs typeface="Calibri" pitchFamily="34" charset="-120"/>
               </a:rPr>
-              <a:t>Any coding agent can read the same feed through an AGENTS.md snippet.</a:t>
+              <a:t>tests passed</a:t>
+            </a:r>
+            <a:endParaRPr lang="en-US" sz="1200" dirty="0"/>
+          </a:p>
+        </p:txBody>
+      </p:sp>
+      <p:sp>
+        <p:nvSpPr>
+          <p:cNvPr id="26" name="Diff removed"/>
+          <p:cNvSpPr txBox="1"/>
+          <p:nvPr/>
+        </p:nvSpPr>
+        <p:spPr>
+          <a:xfrm>
+            <a:off x="960120" y="3566160"/>
+            <a:ext cx="7223760" cy="365760"/>
+          </a:xfrm>
+          <a:prstGeom prst="rect">
+            <a:avLst/>
+          </a:prstGeom>
+          <a:noFill/>
+          <a:ln/>
+        </p:spPr>
+        <p:txBody>
+          <a:bodyPr wrap="square" lIns="0" tIns="0" rIns="0" bIns="0" rtlCol="0" anchor="ctr"/>
+          <a:lstStyle/>
+          <a:p>
+            <a:pPr indent="0" marL="0">
+              <a:buNone/>
+            </a:pPr>
+            <a:r>
+              <a:rPr lang="en-US" sz="1600" dirty="0">
+                <a:solidFill>
+                  <a:srgbClr val="F47067"/>
+                </a:solidFill>
+                <a:latin typeface="Courier New" pitchFamily="34" charset="0"/>
+                <a:ea typeface="Courier New" pitchFamily="34" charset="-122"/>
+                <a:cs typeface="Courier New" pitchFamily="34" charset="-120"/>
+              </a:rPr>
+              <a:t>- body: { prompt, size, user }</a:t>
             </a:r>
             <a:endParaRPr lang="en-US" sz="1600" dirty="0"/>
+          </a:p>
+        </p:txBody>
+      </p:sp>
+      <p:sp>
+        <p:nvSpPr>
+          <p:cNvPr id="27" name="Diff added"/>
+          <p:cNvSpPr txBox="1"/>
+          <p:nvPr/>
+        </p:nvSpPr>
+        <p:spPr>
+          <a:xfrm>
+            <a:off x="960120" y="4023360"/>
+            <a:ext cx="7223760" cy="365760"/>
+          </a:xfrm>
+          <a:prstGeom prst="rect">
+            <a:avLst/>
+          </a:prstGeom>
+          <a:noFill/>
+          <a:ln/>
+        </p:spPr>
+        <p:txBody>
+          <a:bodyPr wrap="square" lIns="0" tIns="0" rIns="0" bIns="0" rtlCol="0" anchor="ctr"/>
+          <a:lstStyle/>
+          <a:p>
+            <a:pPr indent="0" marL="0">
+              <a:buNone/>
+            </a:pPr>
+            <a:r>
+              <a:rPr lang="en-US" sz="1600" dirty="0">
+                <a:solidFill>
+                  <a:srgbClr val="4CC38A"/>
+                </a:solidFill>
+                <a:latin typeface="Courier New" pitchFamily="34" charset="0"/>
+                <a:ea typeface="Courier New" pitchFamily="34" charset="-122"/>
+                <a:cs typeface="Courier New" pitchFamily="34" charset="-120"/>
+              </a:rPr>
+              <a:t>+ body: { prompt, size, model, safety_identifier }</a:t>
+            </a:r>
+            <a:endParaRPr lang="en-US" sz="1600" dirty="0"/>
+          </a:p>
+        </p:txBody>
+      </p:sp>
+      <p:sp>
+        <p:nvSpPr>
+          <p:cNvPr id="28" name="Differentiator"/>
+          <p:cNvSpPr txBox="1"/>
+          <p:nvPr/>
+        </p:nvSpPr>
+        <p:spPr>
+          <a:xfrm>
+            <a:off x="731520" y="4663440"/>
+            <a:ext cx="7680960" cy="384048"/>
+          </a:xfrm>
+          <a:prstGeom prst="rect">
+            <a:avLst/>
+          </a:prstGeom>
+          <a:noFill/>
+          <a:ln/>
+        </p:spPr>
+        <p:txBody>
+          <a:bodyPr wrap="square" lIns="0" tIns="0" rIns="0" bIns="0" rtlCol="0" anchor="t"/>
+          <a:lstStyle/>
+          <a:p>
+            <a:pPr indent="0" marL="0">
+              <a:buNone/>
+            </a:pPr>
+            <a:r>
+              <a:rPr lang="en-US" sz="1100" i="1" dirty="0">
+                <a:solidFill>
+                  <a:srgbClr val="F2A43A"/>
+                </a:solidFill>
+                <a:latin typeface="Calibri" pitchFamily="34" charset="0"/>
+                <a:ea typeface="Calibri" pitchFamily="34" charset="-122"/>
+                <a:cs typeface="Calibri" pitchFamily="34" charset="-120"/>
+              </a:rPr>
+              <a:t>Unlike dependency bots that start from your repo and bump versions, Patchbay starts from the provider's API change and hands every developer team a PR that is already fixed and tested in a clean VM.</a:t>
+            </a:r>
+            <a:endParaRPr lang="en-US" sz="1100" dirty="0"/>
           </a:p>
         </p:txBody>
       </p:sp>
@@ -2856,11 +2781,11 @@
         <p:spPr>
           <a:xfrm>
             <a:off x="731520" y="1417320"/>
-            <a:ext cx="2377440" cy="2697480"/>
+            <a:ext cx="2377440" cy="2286000"/>
           </a:xfrm>
           <a:prstGeom prst="roundRect">
             <a:avLst>
-              <a:gd name="adj" fmla="val 3077"/>
+              <a:gd name="adj" fmla="val 3200"/>
             </a:avLst>
           </a:prstGeom>
           <a:solidFill>
@@ -2876,14 +2801,14 @@
       </p:sp>
       <p:sp>
         <p:nvSpPr>
-          <p:cNvPr id="4" name="Next ring 1"/>
+          <p:cNvPr id="4" name="Next 1 ring"/>
           <p:cNvSpPr/>
           <p:nvPr/>
         </p:nvSpPr>
         <p:spPr>
           <a:xfrm>
-            <a:off x="914400" y="1600200"/>
-            <a:ext cx="502920" cy="502920"/>
+            <a:off x="914400" y="1645920"/>
+            <a:ext cx="731520" cy="731520"/>
           </a:xfrm>
           <a:prstGeom prst="ellipse">
             <a:avLst/>
@@ -2899,45 +2824,30 @@
           </a:ln>
         </p:spPr>
       </p:sp>
-      <p:sp>
-        <p:nvSpPr>
-          <p:cNvPr id="5" name="Next ring 1 label"/>
-          <p:cNvSpPr txBox="1"/>
-          <p:nvPr/>
-        </p:nvSpPr>
-        <p:spPr>
-          <a:xfrm>
-            <a:off x="914400" y="1600200"/>
-            <a:ext cx="502920" cy="502920"/>
-          </a:xfrm>
-          <a:prstGeom prst="rect">
-            <a:avLst/>
-          </a:prstGeom>
-          <a:noFill/>
-          <a:ln/>
-        </p:spPr>
-        <p:txBody>
-          <a:bodyPr wrap="square" lIns="0" tIns="0" rIns="0" bIns="0" rtlCol="0" anchor="ctr"/>
-          <a:lstStyle/>
-          <a:p>
-            <a:pPr algn="ctr" indent="0" marL="0">
-              <a:buNone/>
-            </a:pPr>
-            <a:r>
-              <a:rPr lang="en-US" sz="1600" b="1" dirty="0">
-                <a:solidFill>
-                  <a:srgbClr val="F2A43A"/>
-                </a:solidFill>
-                <a:latin typeface="Calibri" pitchFamily="34" charset="0"/>
-                <a:ea typeface="Calibri" pitchFamily="34" charset="-122"/>
-                <a:cs typeface="Calibri" pitchFamily="34" charset="-120"/>
-              </a:rPr>
-              <a:t>1</a:t>
-            </a:r>
-            <a:endParaRPr lang="en-US" sz="1600" dirty="0"/>
-          </a:p>
-        </p:txBody>
-      </p:sp>
+      <p:pic>
+        <p:nvPicPr>
+          <p:cNvPr id="5" name="Next 1 icon" descr="Next 1">    </p:cNvPr>
+          <p:cNvPicPr>
+            <a:picLocks noChangeAspect="1"/>
+          </p:cNvPicPr>
+          <p:nvPr/>
+        </p:nvPicPr>
+        <p:blipFill>
+          <a:blip r:embed="rId1"/>
+          <a:stretch>
+            <a:fillRect/>
+          </a:stretch>
+        </p:blipFill>
+        <p:spPr>
+          <a:xfrm>
+            <a:off x="1111910" y="1843430"/>
+            <a:ext cx="336499" cy="336499"/>
+          </a:xfrm>
+          <a:prstGeom prst="rect">
+            <a:avLst/>
+          </a:prstGeom>
+        </p:spPr>
+      </p:pic>
       <p:sp>
         <p:nvSpPr>
           <p:cNvPr id="6" name="Next title 1"/>
@@ -2946,7 +2856,7 @@
         </p:nvSpPr>
         <p:spPr>
           <a:xfrm>
-            <a:off x="914400" y="2286000"/>
+            <a:off x="914400" y="2651760"/>
             <a:ext cx="2011680" cy="365760"/>
           </a:xfrm>
           <a:prstGeom prst="rect">
@@ -2985,8 +2895,8 @@
         </p:nvSpPr>
         <p:spPr>
           <a:xfrm>
-            <a:off x="914400" y="2697480"/>
-            <a:ext cx="2011680" cy="1325880"/>
+            <a:off x="914400" y="3063240"/>
+            <a:ext cx="2011680" cy="731520"/>
           </a:xfrm>
           <a:prstGeom prst="rect">
             <a:avLst/>
@@ -3010,7 +2920,7 @@
                 <a:ea typeface="Calibri" pitchFamily="34" charset="-122"/>
                 <a:cs typeface="Calibri" pitchFamily="34" charset="-120"/>
               </a:rPr>
-              <a:t>Start with Stripe's OpenAPI spec. Fintech and health APIs first, where a broken integration is a compliance incident.</a:t>
+              <a:t>OpenAI change done. Stripe next</a:t>
             </a:r>
             <a:endParaRPr lang="en-US" sz="1400" dirty="0"/>
           </a:p>
@@ -3025,11 +2935,11 @@
         <p:spPr>
           <a:xfrm>
             <a:off x="3383280" y="1417320"/>
-            <a:ext cx="2377440" cy="2697480"/>
+            <a:ext cx="2377440" cy="2286000"/>
           </a:xfrm>
           <a:prstGeom prst="roundRect">
             <a:avLst>
-              <a:gd name="adj" fmla="val 3077"/>
+              <a:gd name="adj" fmla="val 3200"/>
             </a:avLst>
           </a:prstGeom>
           <a:solidFill>
@@ -3045,14 +2955,14 @@
       </p:sp>
       <p:sp>
         <p:nvSpPr>
-          <p:cNvPr id="9" name="Next ring 2"/>
+          <p:cNvPr id="9" name="Next 2 ring"/>
           <p:cNvSpPr/>
           <p:nvPr/>
         </p:nvSpPr>
         <p:spPr>
           <a:xfrm>
-            <a:off x="3566160" y="1600200"/>
-            <a:ext cx="502920" cy="502920"/>
+            <a:off x="3566160" y="1645920"/>
+            <a:ext cx="731520" cy="731520"/>
           </a:xfrm>
           <a:prstGeom prst="ellipse">
             <a:avLst/>
@@ -3068,45 +2978,30 @@
           </a:ln>
         </p:spPr>
       </p:sp>
-      <p:sp>
-        <p:nvSpPr>
-          <p:cNvPr id="10" name="Next ring 2 label"/>
-          <p:cNvSpPr txBox="1"/>
-          <p:nvPr/>
-        </p:nvSpPr>
-        <p:spPr>
-          <a:xfrm>
-            <a:off x="3566160" y="1600200"/>
-            <a:ext cx="502920" cy="502920"/>
-          </a:xfrm>
-          <a:prstGeom prst="rect">
-            <a:avLst/>
-          </a:prstGeom>
-          <a:noFill/>
-          <a:ln/>
-        </p:spPr>
-        <p:txBody>
-          <a:bodyPr wrap="square" lIns="0" tIns="0" rIns="0" bIns="0" rtlCol="0" anchor="ctr"/>
-          <a:lstStyle/>
-          <a:p>
-            <a:pPr algn="ctr" indent="0" marL="0">
-              <a:buNone/>
-            </a:pPr>
-            <a:r>
-              <a:rPr lang="en-US" sz="1600" b="1" dirty="0">
-                <a:solidFill>
-                  <a:srgbClr val="F2A43A"/>
-                </a:solidFill>
-                <a:latin typeface="Calibri" pitchFamily="34" charset="0"/>
-                <a:ea typeface="Calibri" pitchFamily="34" charset="-122"/>
-                <a:cs typeface="Calibri" pitchFamily="34" charset="-120"/>
-              </a:rPr>
-              <a:t>2</a:t>
-            </a:r>
-            <a:endParaRPr lang="en-US" sz="1600" dirty="0"/>
-          </a:p>
-        </p:txBody>
-      </p:sp>
+      <p:pic>
+        <p:nvPicPr>
+          <p:cNvPr id="10" name="Next 2 icon" descr="Next 2">    </p:cNvPr>
+          <p:cNvPicPr>
+            <a:picLocks noChangeAspect="1"/>
+          </p:cNvPicPr>
+          <p:nvPr/>
+        </p:nvPicPr>
+        <p:blipFill>
+          <a:blip r:embed="rId2"/>
+          <a:stretch>
+            <a:fillRect/>
+          </a:stretch>
+        </p:blipFill>
+        <p:spPr>
+          <a:xfrm>
+            <a:off x="3763670" y="1843430"/>
+            <a:ext cx="336499" cy="336499"/>
+          </a:xfrm>
+          <a:prstGeom prst="rect">
+            <a:avLst/>
+          </a:prstGeom>
+        </p:spPr>
+      </p:pic>
       <p:sp>
         <p:nvSpPr>
           <p:cNvPr id="11" name="Next title 2"/>
@@ -3115,7 +3010,7 @@
         </p:nvSpPr>
         <p:spPr>
           <a:xfrm>
-            <a:off x="3566160" y="2286000"/>
+            <a:off x="3566160" y="2651760"/>
             <a:ext cx="2011680" cy="365760"/>
           </a:xfrm>
           <a:prstGeom prst="rect">
@@ -3154,8 +3049,8 @@
         </p:nvSpPr>
         <p:spPr>
           <a:xfrm>
-            <a:off x="3566160" y="2697480"/>
-            <a:ext cx="2011680" cy="1325880"/>
+            <a:off x="3566160" y="3063240"/>
+            <a:ext cx="2011680" cy="731520"/>
           </a:xfrm>
           <a:prstGeom prst="rect">
             <a:avLst/>
@@ -3179,7 +3074,7 @@
                 <a:ea typeface="Calibri" pitchFamily="34" charset="-122"/>
                 <a:cs typeface="Calibri" pitchFamily="34" charset="-120"/>
               </a:rPr>
-              <a:t>Per-provider agents ("install Acme Pay's update agent") or one neutral service that tracks many vendors.</a:t>
+              <a:t>Per-provider agents or one neutral service</a:t>
             </a:r>
             <a:endParaRPr lang="en-US" sz="1400" dirty="0"/>
           </a:p>
@@ -3194,11 +3089,11 @@
         <p:spPr>
           <a:xfrm>
             <a:off x="6035040" y="1417320"/>
-            <a:ext cx="2377440" cy="2697480"/>
+            <a:ext cx="2377440" cy="2286000"/>
           </a:xfrm>
           <a:prstGeom prst="roundRect">
             <a:avLst>
-              <a:gd name="adj" fmla="val 3077"/>
+              <a:gd name="adj" fmla="val 3200"/>
             </a:avLst>
           </a:prstGeom>
           <a:solidFill>
@@ -3214,14 +3109,14 @@
       </p:sp>
       <p:sp>
         <p:nvSpPr>
-          <p:cNvPr id="14" name="Next ring 3"/>
+          <p:cNvPr id="14" name="Next 3 ring"/>
           <p:cNvSpPr/>
           <p:nvPr/>
         </p:nvSpPr>
         <p:spPr>
           <a:xfrm>
-            <a:off x="6217920" y="1600200"/>
-            <a:ext cx="502920" cy="502920"/>
+            <a:off x="6217920" y="1645920"/>
+            <a:ext cx="731520" cy="731520"/>
           </a:xfrm>
           <a:prstGeom prst="ellipse">
             <a:avLst/>
@@ -3237,45 +3132,30 @@
           </a:ln>
         </p:spPr>
       </p:sp>
-      <p:sp>
-        <p:nvSpPr>
-          <p:cNvPr id="15" name="Next ring 3 label"/>
-          <p:cNvSpPr txBox="1"/>
-          <p:nvPr/>
-        </p:nvSpPr>
-        <p:spPr>
-          <a:xfrm>
-            <a:off x="6217920" y="1600200"/>
-            <a:ext cx="502920" cy="502920"/>
-          </a:xfrm>
-          <a:prstGeom prst="rect">
-            <a:avLst/>
-          </a:prstGeom>
-          <a:noFill/>
-          <a:ln/>
-        </p:spPr>
-        <p:txBody>
-          <a:bodyPr wrap="square" lIns="0" tIns="0" rIns="0" bIns="0" rtlCol="0" anchor="ctr"/>
-          <a:lstStyle/>
-          <a:p>
-            <a:pPr algn="ctr" indent="0" marL="0">
-              <a:buNone/>
-            </a:pPr>
-            <a:r>
-              <a:rPr lang="en-US" sz="1600" b="1" dirty="0">
-                <a:solidFill>
-                  <a:srgbClr val="F2A43A"/>
-                </a:solidFill>
-                <a:latin typeface="Calibri" pitchFamily="34" charset="0"/>
-                <a:ea typeface="Calibri" pitchFamily="34" charset="-122"/>
-                <a:cs typeface="Calibri" pitchFamily="34" charset="-120"/>
-              </a:rPr>
-              <a:t>3</a:t>
-            </a:r>
-            <a:endParaRPr lang="en-US" sz="1600" dirty="0"/>
-          </a:p>
-        </p:txBody>
-      </p:sp>
+      <p:pic>
+        <p:nvPicPr>
+          <p:cNvPr id="15" name="Next 3 icon" descr="Next 3">    </p:cNvPr>
+          <p:cNvPicPr>
+            <a:picLocks noChangeAspect="1"/>
+          </p:cNvPicPr>
+          <p:nvPr/>
+        </p:nvPicPr>
+        <p:blipFill>
+          <a:blip r:embed="rId3"/>
+          <a:stretch>
+            <a:fillRect/>
+          </a:stretch>
+        </p:blipFill>
+        <p:spPr>
+          <a:xfrm>
+            <a:off x="6415430" y="1843430"/>
+            <a:ext cx="336499" cy="336499"/>
+          </a:xfrm>
+          <a:prstGeom prst="rect">
+            <a:avLst/>
+          </a:prstGeom>
+        </p:spPr>
+      </p:pic>
       <p:sp>
         <p:nvSpPr>
           <p:cNvPr id="16" name="Next title 3"/>
@@ -3284,7 +3164,7 @@
         </p:nvSpPr>
         <p:spPr>
           <a:xfrm>
-            <a:off x="6217920" y="2286000"/>
+            <a:off x="6217920" y="2651760"/>
             <a:ext cx="2011680" cy="365760"/>
           </a:xfrm>
           <a:prstGeom prst="rect">
@@ -3323,8 +3203,8 @@
         </p:nvSpPr>
         <p:spPr>
           <a:xfrm>
-            <a:off x="6217920" y="2697480"/>
-            <a:ext cx="2011680" cy="1325880"/>
+            <a:off x="6217920" y="3063240"/>
+            <a:ext cx="2011680" cy="731520"/>
           </a:xfrm>
           <a:prstGeom prst="rect">
             <a:avLst/>
@@ -3348,7 +3228,7 @@
                 <a:ea typeface="Calibri" pitchFamily="34" charset="-122"/>
                 <a:cs typeface="Calibri" pitchFamily="34" charset="-120"/>
               </a:rPr>
-              <a:t>Providers own the cost of unread changelogs. Customers review and merge for free.</a:t>
+              <a:t>Developer teams review and merge</a:t>
             </a:r>
             <a:endParaRPr lang="en-US" sz="1400" dirty="0"/>
           </a:p>
@@ -3362,7 +3242,7 @@
         </p:nvSpPr>
         <p:spPr>
           <a:xfrm>
-            <a:off x="731520" y="4389120"/>
+            <a:off x="731520" y="4069080"/>
             <a:ext cx="7680960" cy="365760"/>
           </a:xfrm>
           <a:prstGeom prst="rect">
@@ -3387,7 +3267,7 @@
                 <a:ea typeface="Cambria" pitchFamily="34" charset="-122"/>
                 <a:cs typeface="Cambria" pitchFamily="34" charset="-120"/>
               </a:rPr>
-              <a:t>The provider ships once. Every customer is patched.</a:t>
+              <a:t>The provider ships once. Every developer team gets a tested PR.</a:t>
             </a:r>
             <a:endParaRPr lang="en-US" sz="2000" dirty="0"/>
           </a:p>

</xml_diff>